<commit_message>
Rebaseline 2026-08-01 trend edition against 31 Jul (honest quiet-day check-in)
Corrected the framing after finding the Box archive carries six later
editions than the git repo's July 18 report; the true last edition is
31 Jul 'The Scoreboard Arrives'. One day on, no significant new data has
landed, so this is an honest quiet-day confirmation: the measured
picture (AI #1 layoff reason, Stanford -13% entry-level, LinkedIn AI
literacy #1) stands. Retained only genuinely-unlogged minor texture
(ADP seniority ladder, role-based anxiety, wellness festivalization),
clearly caveated, plus the carry-forward Judgment Journal tool.

Co-Authored-By: Claude Opus 4.8 <noreply@anthropic.com>
Claude-Session: https://claude.ai/code/session_013B9xhgRKvZcTyz8WVWvsDt
</commit_message>
<xml_diff>
--- a/free_education/2026-08-01-skills-ai-delta/AI_Skills_Learning_Delta_2026-08.pptx
+++ b/free_education/2026-08-01-skills-ai-delta/AI_Skills_Learning_Delta_2026-08.pptx
@@ -10,7 +10,6 @@
     <p:sldId id="258" r:id="rId9"/>
     <p:sldId id="259" r:id="rId10"/>
     <p:sldId id="260" r:id="rId11"/>
-    <p:sldId id="261" r:id="rId12"/>
   </p:sldIdLst>
   <p:sldSz cx="12191695" cy="6858000" type="screen4x3"/>
   <p:notesSz cx="6858000" cy="9144000"/>
@@ -3116,11 +3115,11 @@
             <a:avLst/>
           </a:prstGeom>
           <a:solidFill>
-            <a:srgbClr val="E85D2E"/>
+            <a:srgbClr val="2EA05A"/>
           </a:solidFill>
           <a:ln w="6350">
             <a:solidFill>
-              <a:srgbClr val="E85D2E"/>
+              <a:srgbClr val="2EA05A"/>
             </a:solidFill>
           </a:ln>
           <a:effectLst/>
@@ -3175,13 +3174,13 @@
               </a:lnSpc>
             </a:pPr>
             <a:r>
-              <a:rPr sz="5800" b="1" i="0">
+              <a:rPr sz="6000" b="1" i="0">
                 <a:solidFill>
                   <a:srgbClr val="1D1D2B"/>
                 </a:solidFill>
                 <a:latin typeface="Comic Sans MS"/>
               </a:rPr>
-              <a:t>The Anxiety Ladder</a:t>
+              <a:t>Quiet Day</a:t>
             </a:r>
           </a:p>
         </p:txBody>
@@ -3195,17 +3194,17 @@
         <p:spPr>
           <a:xfrm>
             <a:off x="868680" y="2514600"/>
-            <a:ext cx="5486400" cy="109728"/>
+            <a:ext cx="4572000" cy="109728"/>
           </a:xfrm>
           <a:prstGeom prst="roundRect">
             <a:avLst/>
           </a:prstGeom>
           <a:solidFill>
-            <a:srgbClr val="E85D2E"/>
+            <a:srgbClr val="2EA05A"/>
           </a:solidFill>
           <a:ln w="6350">
             <a:solidFill>
-              <a:srgbClr val="E85D2E"/>
+              <a:srgbClr val="2EA05A"/>
             </a:solidFill>
           </a:ln>
           <a:effectLst/>
@@ -3266,7 +3265,7 @@
                 </a:solidFill>
                 <a:latin typeface="Comic Sans MS"/>
               </a:rPr>
-              <a:t>Same numbers, sharper picture</a:t>
+              <a:t>The Scoreboard still stands</a:t>
             </a:r>
           </a:p>
         </p:txBody>
@@ -3305,7 +3304,7 @@
                 </a:solidFill>
                 <a:latin typeface="Comic Sans MS"/>
               </a:rPr>
-              <a:t>The headline data hasn't moved. What sharpened: AI anxiety is now</a:t>
+              <a:t>One day on from the 31 July brief, no significant new data landed.</a:t>
             </a:r>
           </a:p>
           <a:p>
@@ -3321,7 +3320,7 @@
                 </a:solidFill>
                 <a:latin typeface="Comic Sans MS"/>
               </a:rPr>
-              <a:t>STRATIFIED by seniority and role — and learning is going social.</a:t>
+              <a:t>The big move was last week: forecast → measured. Today = honest confirmation.</a:t>
             </a:r>
           </a:p>
         </p:txBody>
@@ -3360,7 +3359,7 @@
                 </a:solidFill>
                 <a:latin typeface="Comic Sans MS"/>
               </a:rPr>
-              <a:t>5-minute delta update  ·  Trend monitor  ·  1 August 2026</a:t>
+              <a:t>5-minute check-in  ·  Trend monitor  ·  1 August 2026</a:t>
             </a:r>
           </a:p>
         </p:txBody>
@@ -3400,7 +3399,7 @@
         <p:spPr>
           <a:xfrm>
             <a:off x="640080" y="365760"/>
-            <a:ext cx="10972800" cy="822960"/>
+            <a:ext cx="11155680" cy="822960"/>
           </a:xfrm>
           <a:prstGeom prst="rect">
             <a:avLst/>
@@ -3425,7 +3424,7 @@
                 </a:solidFill>
                 <a:latin typeface="Comic Sans MS"/>
               </a:rPr>
-              <a:t>First, the honest headline: flagship data is UNCHANGED</a:t>
+              <a:t>Where the story stands (31 Jul — still current)</a:t>
             </a:r>
           </a:p>
         </p:txBody>
@@ -3439,17 +3438,17 @@
         <p:spPr>
           <a:xfrm>
             <a:off x="685800" y="1143000"/>
-            <a:ext cx="6949440" cy="109728"/>
+            <a:ext cx="6766560" cy="109728"/>
           </a:xfrm>
           <a:prstGeom prst="roundRect">
             <a:avLst/>
           </a:prstGeom>
           <a:solidFill>
-            <a:srgbClr val="6B665C"/>
+            <a:srgbClr val="2EA05A"/>
           </a:solidFill>
           <a:ln w="6350">
             <a:solidFill>
-              <a:srgbClr val="6B665C"/>
+              <a:srgbClr val="2EA05A"/>
             </a:solidFill>
           </a:ln>
           <a:effectLst/>
@@ -3485,7 +3484,7 @@
         <p:spPr>
           <a:xfrm>
             <a:off x="685800" y="1325880"/>
-            <a:ext cx="10881360" cy="548640"/>
+            <a:ext cx="10881360" cy="502920"/>
           </a:xfrm>
           <a:prstGeom prst="rect">
             <a:avLst/>
@@ -3510,29 +3509,31 @@
                 </a:solidFill>
                 <a:latin typeface="Comic Sans MS"/>
               </a:rPr>
-              <a:t>No major new report in 2 weeks. Re-verified 1 Aug — the July pillars still stand:</a:t>
-            </a:r>
-          </a:p>
-        </p:txBody>
-      </p:sp>
-      <p:sp>
-        <p:nvSpPr>
-          <p:cNvPr id="5" name="Rounded Rectangle 4"/>
+              <a:t>The measured picture from last week hasn't been superseded — it remains the plan:</a:t>
+            </a:r>
+          </a:p>
+        </p:txBody>
+      </p:sp>
+      <p:sp>
+        <p:nvSpPr>
+          <p:cNvPr id="5" name="Oval 4"/>
           <p:cNvSpPr/>
           <p:nvPr/>
         </p:nvSpPr>
         <p:spPr>
           <a:xfrm>
-            <a:off x="822960" y="2194560"/>
-            <a:ext cx="3383280" cy="1417320"/>
-          </a:xfrm>
-          <a:prstGeom prst="roundRect">
-            <a:avLst/>
-          </a:prstGeom>
-          <a:noFill/>
-          <a:ln w="25400">
+            <a:off x="731520" y="2203704"/>
+            <a:ext cx="201168" cy="201168"/>
+          </a:xfrm>
+          <a:prstGeom prst="ellipse">
+            <a:avLst/>
+          </a:prstGeom>
+          <a:solidFill>
+            <a:srgbClr val="E85D2E"/>
+          </a:solidFill>
+          <a:ln w="6350">
             <a:solidFill>
-              <a:srgbClr val="6B665C"/>
+              <a:srgbClr val="E85D2E"/>
             </a:solidFill>
           </a:ln>
           <a:effectLst/>
@@ -3567,8 +3568,8 @@
         </p:nvSpPr>
         <p:spPr>
           <a:xfrm>
-            <a:off x="822960" y="2304288"/>
-            <a:ext cx="3383280" cy="640080"/>
+            <a:off x="1097280" y="2057400"/>
+            <a:ext cx="4572000" cy="640080"/>
           </a:xfrm>
           <a:prstGeom prst="rect">
             <a:avLst/>
@@ -3576,24 +3577,24 @@
           <a:noFill/>
         </p:spPr>
         <p:txBody>
-          <a:bodyPr wrap="square" anchor="t">
+          <a:bodyPr wrap="square" anchor="ctr">
             <a:spAutoFit/>
           </a:bodyPr>
           <a:lstStyle/>
           <a:p>
-            <a:pPr algn="ctr">
+            <a:pPr algn="l">
               <a:lnSpc>
                 <a:spcPct val="105000"/>
               </a:lnSpc>
             </a:pPr>
             <a:r>
-              <a:rPr sz="3400" b="1" i="0">
-                <a:solidFill>
-                  <a:srgbClr val="6B665C"/>
+              <a:rPr sz="1800" b="1" i="0">
+                <a:solidFill>
+                  <a:srgbClr val="1D1D2B"/>
                 </a:solidFill>
                 <a:latin typeface="Comic Sans MS"/>
               </a:rPr>
-              <a:t>+62%</a:t>
+              <a:t>AI = #1 stated layoff reason</a:t>
             </a:r>
           </a:p>
         </p:txBody>
@@ -3606,8 +3607,8 @@
         </p:nvSpPr>
         <p:spPr>
           <a:xfrm>
-            <a:off x="822960" y="3017520"/>
-            <a:ext cx="3383280" cy="457200"/>
+            <a:off x="5669280" y="2057400"/>
+            <a:ext cx="5943600" cy="640080"/>
           </a:xfrm>
           <a:prstGeom prst="rect">
             <a:avLst/>
@@ -3615,46 +3616,48 @@
           <a:noFill/>
         </p:spPr>
         <p:txBody>
-          <a:bodyPr wrap="square" anchor="t">
+          <a:bodyPr wrap="square" anchor="ctr">
             <a:spAutoFit/>
           </a:bodyPr>
           <a:lstStyle/>
           <a:p>
-            <a:pPr algn="ctr">
+            <a:pPr algn="l">
               <a:lnSpc>
                 <a:spcPct val="105000"/>
               </a:lnSpc>
             </a:pPr>
             <a:r>
-              <a:rPr sz="1600" b="0" i="0">
-                <a:solidFill>
-                  <a:srgbClr val="1D1D2B"/>
+              <a:rPr sz="1500" b="0" i="0">
+                <a:solidFill>
+                  <a:srgbClr val="6B665C"/>
                 </a:solidFill>
                 <a:latin typeface="Comic Sans MS"/>
               </a:rPr>
-              <a:t>wage premium</a:t>
-            </a:r>
-          </a:p>
-        </p:txBody>
-      </p:sp>
-      <p:sp>
-        <p:nvSpPr>
-          <p:cNvPr id="8" name="Rounded Rectangle 7"/>
+              <a:t>4 months running · ~101,743 AI-cited cuts H1 (≈2× 2025)</a:t>
+            </a:r>
+          </a:p>
+        </p:txBody>
+      </p:sp>
+      <p:sp>
+        <p:nvSpPr>
+          <p:cNvPr id="8" name="Oval 7"/>
           <p:cNvSpPr/>
           <p:nvPr/>
         </p:nvSpPr>
         <p:spPr>
           <a:xfrm>
-            <a:off x="4526280" y="2194560"/>
-            <a:ext cx="3383280" cy="1417320"/>
-          </a:xfrm>
-          <a:prstGeom prst="roundRect">
-            <a:avLst/>
-          </a:prstGeom>
-          <a:noFill/>
-          <a:ln w="25400">
+            <a:off x="731520" y="2980944"/>
+            <a:ext cx="201168" cy="201168"/>
+          </a:xfrm>
+          <a:prstGeom prst="ellipse">
+            <a:avLst/>
+          </a:prstGeom>
+          <a:solidFill>
+            <a:srgbClr val="E85D2E"/>
+          </a:solidFill>
+          <a:ln w="6350">
             <a:solidFill>
-              <a:srgbClr val="6B665C"/>
+              <a:srgbClr val="E85D2E"/>
             </a:solidFill>
           </a:ln>
           <a:effectLst/>
@@ -3689,8 +3692,8 @@
         </p:nvSpPr>
         <p:spPr>
           <a:xfrm>
-            <a:off x="4526280" y="2304288"/>
-            <a:ext cx="3383280" cy="640080"/>
+            <a:off x="1097280" y="2834640"/>
+            <a:ext cx="4572000" cy="640080"/>
           </a:xfrm>
           <a:prstGeom prst="rect">
             <a:avLst/>
@@ -3698,24 +3701,24 @@
           <a:noFill/>
         </p:spPr>
         <p:txBody>
-          <a:bodyPr wrap="square" anchor="t">
+          <a:bodyPr wrap="square" anchor="ctr">
             <a:spAutoFit/>
           </a:bodyPr>
           <a:lstStyle/>
           <a:p>
-            <a:pPr algn="ctr">
+            <a:pPr algn="l">
               <a:lnSpc>
                 <a:spcPct val="105000"/>
               </a:lnSpc>
             </a:pPr>
             <a:r>
-              <a:rPr sz="3400" b="1" i="0">
-                <a:solidFill>
-                  <a:srgbClr val="6B665C"/>
+              <a:rPr sz="1800" b="1" i="0">
+                <a:solidFill>
+                  <a:srgbClr val="1D1D2B"/>
                 </a:solidFill>
                 <a:latin typeface="Comic Sans MS"/>
               </a:rPr>
-              <a:t>~8×</a:t>
+              <a:t>Entry-level −13% (measured)</a:t>
             </a:r>
           </a:p>
         </p:txBody>
@@ -3728,8 +3731,8 @@
         </p:nvSpPr>
         <p:spPr>
           <a:xfrm>
-            <a:off x="4526280" y="3017520"/>
-            <a:ext cx="3383280" cy="457200"/>
+            <a:off x="5669280" y="2834640"/>
+            <a:ext cx="5943600" cy="640080"/>
           </a:xfrm>
           <a:prstGeom prst="rect">
             <a:avLst/>
@@ -3737,46 +3740,48 @@
           <a:noFill/>
         </p:spPr>
         <p:txBody>
-          <a:bodyPr wrap="square" anchor="t">
+          <a:bodyPr wrap="square" anchor="ctr">
             <a:spAutoFit/>
           </a:bodyPr>
           <a:lstStyle/>
           <a:p>
-            <a:pPr algn="ctr">
+            <a:pPr algn="l">
               <a:lnSpc>
                 <a:spcPct val="105000"/>
               </a:lnSpc>
             </a:pPr>
             <a:r>
-              <a:rPr sz="1600" b="0" i="0">
-                <a:solidFill>
-                  <a:srgbClr val="1D1D2B"/>
+              <a:rPr sz="1500" b="0" i="0">
+                <a:solidFill>
+                  <a:srgbClr val="6B665C"/>
                 </a:solidFill>
                 <a:latin typeface="Comic Sans MS"/>
               </a:rPr>
-              <a:t>faster AI-job growth</a:t>
-            </a:r>
-          </a:p>
-        </p:txBody>
-      </p:sp>
-      <p:sp>
-        <p:nvSpPr>
-          <p:cNvPr id="11" name="Rounded Rectangle 10"/>
+              <a:t>22–25s in AI-exposed jobs; −20% junior devs — Stanford payroll</a:t>
+            </a:r>
+          </a:p>
+        </p:txBody>
+      </p:sp>
+      <p:sp>
+        <p:nvSpPr>
+          <p:cNvPr id="11" name="Oval 10"/>
           <p:cNvSpPr/>
           <p:nvPr/>
         </p:nvSpPr>
         <p:spPr>
           <a:xfrm>
-            <a:off x="8229600" y="2194560"/>
-            <a:ext cx="3383280" cy="1417320"/>
-          </a:xfrm>
-          <a:prstGeom prst="roundRect">
-            <a:avLst/>
-          </a:prstGeom>
-          <a:noFill/>
-          <a:ln w="25400">
+            <a:off x="731520" y="3758184"/>
+            <a:ext cx="201168" cy="201168"/>
+          </a:xfrm>
+          <a:prstGeom prst="ellipse">
+            <a:avLst/>
+          </a:prstGeom>
+          <a:solidFill>
+            <a:srgbClr val="2E6BE8"/>
+          </a:solidFill>
+          <a:ln w="6350">
             <a:solidFill>
-              <a:srgbClr val="6B665C"/>
+              <a:srgbClr val="2E6BE8"/>
             </a:solidFill>
           </a:ln>
           <a:effectLst/>
@@ -3811,8 +3816,8 @@
         </p:nvSpPr>
         <p:spPr>
           <a:xfrm>
-            <a:off x="8229600" y="2304288"/>
-            <a:ext cx="3383280" cy="640080"/>
+            <a:off x="1097280" y="3611880"/>
+            <a:ext cx="4572000" cy="640080"/>
           </a:xfrm>
           <a:prstGeom prst="rect">
             <a:avLst/>
@@ -3820,24 +3825,24 @@
           <a:noFill/>
         </p:spPr>
         <p:txBody>
-          <a:bodyPr wrap="square" anchor="t">
+          <a:bodyPr wrap="square" anchor="ctr">
             <a:spAutoFit/>
           </a:bodyPr>
           <a:lstStyle/>
           <a:p>
-            <a:pPr algn="ctr">
+            <a:pPr algn="l">
               <a:lnSpc>
                 <a:spcPct val="105000"/>
               </a:lnSpc>
             </a:pPr>
             <a:r>
-              <a:rPr sz="3400" b="1" i="0">
-                <a:solidFill>
-                  <a:srgbClr val="6B665C"/>
+              <a:rPr sz="1800" b="1" i="0">
+                <a:solidFill>
+                  <a:srgbClr val="1D1D2B"/>
                 </a:solidFill>
                 <a:latin typeface="Comic Sans MS"/>
               </a:rPr>
-              <a:t>51%</a:t>
+              <a:t>AI literacy = #1 rising skill</a:t>
             </a:r>
           </a:p>
         </p:txBody>
@@ -3850,8 +3855,8 @@
         </p:nvSpPr>
         <p:spPr>
           <a:xfrm>
-            <a:off x="8229600" y="3017520"/>
-            <a:ext cx="3383280" cy="457200"/>
+            <a:off x="5669280" y="3611880"/>
+            <a:ext cx="5943600" cy="640080"/>
           </a:xfrm>
           <a:prstGeom prst="rect">
             <a:avLst/>
@@ -3859,46 +3864,48 @@
           <a:noFill/>
         </p:spPr>
         <p:txBody>
-          <a:bodyPr wrap="square" anchor="t">
+          <a:bodyPr wrap="square" anchor="ctr">
             <a:spAutoFit/>
           </a:bodyPr>
           <a:lstStyle/>
           <a:p>
-            <a:pPr algn="ctr">
+            <a:pPr algn="l">
               <a:lnSpc>
                 <a:spcPct val="105000"/>
               </a:lnSpc>
             </a:pPr>
             <a:r>
-              <a:rPr sz="1600" b="0" i="0">
-                <a:solidFill>
-                  <a:srgbClr val="1D1D2B"/>
+              <a:rPr sz="1500" b="0" i="0">
+                <a:solidFill>
+                  <a:srgbClr val="6B665C"/>
                 </a:solidFill>
                 <a:latin typeface="Comic Sans MS"/>
               </a:rPr>
-              <a:t>AI jobs outside IT</a:t>
-            </a:r>
-          </a:p>
-        </p:txBody>
-      </p:sp>
-      <p:sp>
-        <p:nvSpPr>
-          <p:cNvPr id="14" name="Rounded Rectangle 13"/>
+              <a:t>soft skills take 7 of top 10 — LinkedIn 2026</a:t>
+            </a:r>
+          </a:p>
+        </p:txBody>
+      </p:sp>
+      <p:sp>
+        <p:nvSpPr>
+          <p:cNvPr id="14" name="Oval 13"/>
           <p:cNvSpPr/>
           <p:nvPr/>
         </p:nvSpPr>
         <p:spPr>
           <a:xfrm>
-            <a:off x="822960" y="3977639"/>
-            <a:ext cx="3383280" cy="1417320"/>
-          </a:xfrm>
-          <a:prstGeom prst="roundRect">
-            <a:avLst/>
-          </a:prstGeom>
-          <a:noFill/>
-          <a:ln w="25400">
+            <a:off x="731520" y="4535424"/>
+            <a:ext cx="201168" cy="201168"/>
+          </a:xfrm>
+          <a:prstGeom prst="ellipse">
+            <a:avLst/>
+          </a:prstGeom>
+          <a:solidFill>
+            <a:srgbClr val="2E6BE8"/>
+          </a:solidFill>
+          <a:ln w="6350">
             <a:solidFill>
-              <a:srgbClr val="6B665C"/>
+              <a:srgbClr val="2E6BE8"/>
             </a:solidFill>
           </a:ln>
           <a:effectLst/>
@@ -3933,8 +3940,8 @@
         </p:nvSpPr>
         <p:spPr>
           <a:xfrm>
-            <a:off x="822960" y="4087368"/>
-            <a:ext cx="3383280" cy="640080"/>
+            <a:off x="1097280" y="4389120"/>
+            <a:ext cx="4572000" cy="640080"/>
           </a:xfrm>
           <a:prstGeom prst="rect">
             <a:avLst/>
@@ -3942,24 +3949,24 @@
           <a:noFill/>
         </p:spPr>
         <p:txBody>
-          <a:bodyPr wrap="square" anchor="t">
+          <a:bodyPr wrap="square" anchor="ctr">
             <a:spAutoFit/>
           </a:bodyPr>
           <a:lstStyle/>
           <a:p>
-            <a:pPr algn="ctr">
+            <a:pPr algn="l">
               <a:lnSpc>
                 <a:spcPct val="105000"/>
               </a:lnSpc>
             </a:pPr>
             <a:r>
-              <a:rPr sz="3400" b="1" i="0">
-                <a:solidFill>
-                  <a:srgbClr val="6B665C"/>
+              <a:rPr sz="1800" b="1" i="0">
+                <a:solidFill>
+                  <a:srgbClr val="1D1D2B"/>
                 </a:solidFill>
                 <a:latin typeface="Comic Sans MS"/>
               </a:rPr>
-              <a:t>22%</a:t>
+              <a:t>Trained for today's AI</a:t>
             </a:r>
           </a:p>
         </p:txBody>
@@ -3972,8 +3979,8 @@
         </p:nvSpPr>
         <p:spPr>
           <a:xfrm>
-            <a:off x="822960" y="4800600"/>
-            <a:ext cx="3383280" cy="457200"/>
+            <a:off x="5669280" y="4389120"/>
+            <a:ext cx="5943600" cy="640080"/>
           </a:xfrm>
           <a:prstGeom prst="rect">
             <a:avLst/>
@@ -3981,46 +3988,48 @@
           <a:noFill/>
         </p:spPr>
         <p:txBody>
-          <a:bodyPr wrap="square" anchor="t">
+          <a:bodyPr wrap="square" anchor="ctr">
             <a:spAutoFit/>
           </a:bodyPr>
           <a:lstStyle/>
           <a:p>
-            <a:pPr algn="ctr">
+            <a:pPr algn="l">
               <a:lnSpc>
                 <a:spcPct val="105000"/>
               </a:lnSpc>
             </a:pPr>
             <a:r>
-              <a:rPr sz="1600" b="0" i="0">
-                <a:solidFill>
-                  <a:srgbClr val="1D1D2B"/>
+              <a:rPr sz="1500" b="0" i="0">
+                <a:solidFill>
+                  <a:srgbClr val="6B665C"/>
                 </a:solidFill>
                 <a:latin typeface="Comic Sans MS"/>
               </a:rPr>
-              <a:t>feel job-safe</a:t>
-            </a:r>
-          </a:p>
-        </p:txBody>
-      </p:sp>
-      <p:sp>
-        <p:nvSpPr>
-          <p:cNvPr id="17" name="Rounded Rectangle 16"/>
+              <a:t>not tomorrow's job — Conference Board (28 Jul)</a:t>
+            </a:r>
+          </a:p>
+        </p:txBody>
+      </p:sp>
+      <p:sp>
+        <p:nvSpPr>
+          <p:cNvPr id="17" name="Oval 16"/>
           <p:cNvSpPr/>
           <p:nvPr/>
         </p:nvSpPr>
         <p:spPr>
           <a:xfrm>
-            <a:off x="4526280" y="3977639"/>
-            <a:ext cx="3383280" cy="1417320"/>
-          </a:xfrm>
-          <a:prstGeom prst="roundRect">
-            <a:avLst/>
-          </a:prstGeom>
-          <a:noFill/>
-          <a:ln w="25400">
+            <a:off x="731520" y="5312664"/>
+            <a:ext cx="201168" cy="201168"/>
+          </a:xfrm>
+          <a:prstGeom prst="ellipse">
+            <a:avLst/>
+          </a:prstGeom>
+          <a:solidFill>
+            <a:srgbClr val="2EA05A"/>
+          </a:solidFill>
+          <a:ln w="6350">
             <a:solidFill>
-              <a:srgbClr val="6B665C"/>
+              <a:srgbClr val="2EA05A"/>
             </a:solidFill>
           </a:ln>
           <a:effectLst/>
@@ -4055,8 +4064,8 @@
         </p:nvSpPr>
         <p:spPr>
           <a:xfrm>
-            <a:off x="4526280" y="4087368"/>
-            <a:ext cx="3383280" cy="640080"/>
+            <a:off x="1097280" y="5166360"/>
+            <a:ext cx="4572000" cy="640080"/>
           </a:xfrm>
           <a:prstGeom prst="rect">
             <a:avLst/>
@@ -4064,207 +4073,7 @@
           <a:noFill/>
         </p:spPr>
         <p:txBody>
-          <a:bodyPr wrap="square" anchor="t">
-            <a:spAutoFit/>
-          </a:bodyPr>
-          <a:lstStyle/>
-          <a:p>
-            <a:pPr algn="ctr">
-              <a:lnSpc>
-                <a:spcPct val="105000"/>
-              </a:lnSpc>
-            </a:pPr>
-            <a:r>
-              <a:rPr sz="3400" b="1" i="0">
-                <a:solidFill>
-                  <a:srgbClr val="6B665C"/>
-                </a:solidFill>
-                <a:latin typeface="Comic Sans MS"/>
-              </a:rPr>
-              <a:t>48%</a:t>
-            </a:r>
-          </a:p>
-        </p:txBody>
-      </p:sp>
-      <p:sp>
-        <p:nvSpPr>
-          <p:cNvPr id="19" name="TextBox 18"/>
-          <p:cNvSpPr txBox="1"/>
-          <p:nvPr/>
-        </p:nvSpPr>
-        <p:spPr>
-          <a:xfrm>
-            <a:off x="4526280" y="4800600"/>
-            <a:ext cx="3383280" cy="457200"/>
-          </a:xfrm>
-          <a:prstGeom prst="rect">
-            <a:avLst/>
-          </a:prstGeom>
-          <a:noFill/>
-        </p:spPr>
-        <p:txBody>
-          <a:bodyPr wrap="square" anchor="t">
-            <a:spAutoFit/>
-          </a:bodyPr>
-          <a:lstStyle/>
-          <a:p>
-            <a:pPr algn="ctr">
-              <a:lnSpc>
-                <a:spcPct val="105000"/>
-              </a:lnSpc>
-            </a:pPr>
-            <a:r>
-              <a:rPr sz="1600" b="0" i="0">
-                <a:solidFill>
-                  <a:srgbClr val="1D1D2B"/>
-                </a:solidFill>
-                <a:latin typeface="Comic Sans MS"/>
-              </a:rPr>
-              <a:t>plan a skilliday</a:t>
-            </a:r>
-          </a:p>
-        </p:txBody>
-      </p:sp>
-      <p:sp>
-        <p:nvSpPr>
-          <p:cNvPr id="20" name="Rounded Rectangle 19"/>
-          <p:cNvSpPr/>
-          <p:nvPr/>
-        </p:nvSpPr>
-        <p:spPr>
-          <a:xfrm>
-            <a:off x="8229600" y="3977639"/>
-            <a:ext cx="3383280" cy="1417320"/>
-          </a:xfrm>
-          <a:prstGeom prst="roundRect">
-            <a:avLst/>
-          </a:prstGeom>
-          <a:noFill/>
-          <a:ln w="25400">
-            <a:solidFill>
-              <a:srgbClr val="6B665C"/>
-            </a:solidFill>
-          </a:ln>
-          <a:effectLst/>
-        </p:spPr>
-        <p:style>
-          <a:lnRef idx="1">
-            <a:schemeClr val="accent1"/>
-          </a:lnRef>
-          <a:fillRef idx="3">
-            <a:schemeClr val="accent1"/>
-          </a:fillRef>
-          <a:effectRef idx="2">
-            <a:schemeClr val="accent1"/>
-          </a:effectRef>
-          <a:fontRef idx="minor">
-            <a:schemeClr val="lt1"/>
-          </a:fontRef>
-        </p:style>
-        <p:txBody>
-          <a:bodyPr rtlCol="0" anchor="ctr"/>
-          <a:lstStyle/>
-          <a:p>
-            <a:pPr algn="ctr"/>
-          </a:p>
-        </p:txBody>
-      </p:sp>
-      <p:sp>
-        <p:nvSpPr>
-          <p:cNvPr id="21" name="TextBox 20"/>
-          <p:cNvSpPr txBox="1"/>
-          <p:nvPr/>
-        </p:nvSpPr>
-        <p:spPr>
-          <a:xfrm>
-            <a:off x="8229600" y="4087368"/>
-            <a:ext cx="3383280" cy="640080"/>
-          </a:xfrm>
-          <a:prstGeom prst="rect">
-            <a:avLst/>
-          </a:prstGeom>
-          <a:noFill/>
-        </p:spPr>
-        <p:txBody>
-          <a:bodyPr wrap="square" anchor="t">
-            <a:spAutoFit/>
-          </a:bodyPr>
-          <a:lstStyle/>
-          <a:p>
-            <a:pPr algn="ctr">
-              <a:lnSpc>
-                <a:spcPct val="105000"/>
-              </a:lnSpc>
-            </a:pPr>
-            <a:r>
-              <a:rPr sz="3400" b="1" i="0">
-                <a:solidFill>
-                  <a:srgbClr val="6B665C"/>
-                </a:solidFill>
-                <a:latin typeface="Comic Sans MS"/>
-              </a:rPr>
-              <a:t>50%</a:t>
-            </a:r>
-          </a:p>
-        </p:txBody>
-      </p:sp>
-      <p:sp>
-        <p:nvSpPr>
-          <p:cNvPr id="22" name="TextBox 21"/>
-          <p:cNvSpPr txBox="1"/>
-          <p:nvPr/>
-        </p:nvSpPr>
-        <p:spPr>
-          <a:xfrm>
-            <a:off x="8229600" y="4800600"/>
-            <a:ext cx="3383280" cy="457200"/>
-          </a:xfrm>
-          <a:prstGeom prst="rect">
-            <a:avLst/>
-          </a:prstGeom>
-          <a:noFill/>
-        </p:spPr>
-        <p:txBody>
-          <a:bodyPr wrap="square" anchor="t">
-            <a:spAutoFit/>
-          </a:bodyPr>
-          <a:lstStyle/>
-          <a:p>
-            <a:pPr algn="ctr">
-              <a:lnSpc>
-                <a:spcPct val="105000"/>
-              </a:lnSpc>
-            </a:pPr>
-            <a:r>
-              <a:rPr sz="1600" b="0" i="0">
-                <a:solidFill>
-                  <a:srgbClr val="1D1D2B"/>
-                </a:solidFill>
-                <a:latin typeface="Comic Sans MS"/>
-              </a:rPr>
-              <a:t>orgs → AI-free tests</a:t>
-            </a:r>
-          </a:p>
-        </p:txBody>
-      </p:sp>
-      <p:sp>
-        <p:nvSpPr>
-          <p:cNvPr id="23" name="TextBox 22"/>
-          <p:cNvSpPr txBox="1"/>
-          <p:nvPr/>
-        </p:nvSpPr>
-        <p:spPr>
-          <a:xfrm>
-            <a:off x="822960" y="6172200"/>
-            <a:ext cx="10972800" cy="457200"/>
-          </a:xfrm>
-          <a:prstGeom prst="rect">
-            <a:avLst/>
-          </a:prstGeom>
-          <a:noFill/>
-        </p:spPr>
-        <p:txBody>
-          <a:bodyPr wrap="square" anchor="t">
+          <a:bodyPr wrap="square" anchor="ctr">
             <a:spAutoFit/>
           </a:bodyPr>
           <a:lstStyle/>
@@ -4275,13 +4084,91 @@
               </a:lnSpc>
             </a:pPr>
             <a:r>
-              <a:rPr sz="1400" b="0" i="1">
-                <a:solidFill>
-                  <a:srgbClr val="E85D2E"/>
+              <a:rPr sz="1800" b="1" i="0">
+                <a:solidFill>
+                  <a:srgbClr val="1D1D2B"/>
                 </a:solidFill>
                 <a:latin typeface="Comic Sans MS"/>
               </a:rPr>
-              <a:t>⏸  Track only headlines? Nothing new to act on — the July playbook holds. The value is underneath. →</a:t>
+              <a:t>+62% premium · 22% feel safe</a:t>
+            </a:r>
+          </a:p>
+        </p:txBody>
+      </p:sp>
+      <p:sp>
+        <p:nvSpPr>
+          <p:cNvPr id="19" name="TextBox 18"/>
+          <p:cNvSpPr txBox="1"/>
+          <p:nvPr/>
+        </p:nvSpPr>
+        <p:spPr>
+          <a:xfrm>
+            <a:off x="5669280" y="5166360"/>
+            <a:ext cx="5943600" cy="640080"/>
+          </a:xfrm>
+          <a:prstGeom prst="rect">
+            <a:avLst/>
+          </a:prstGeom>
+          <a:noFill/>
+        </p:spPr>
+        <p:txBody>
+          <a:bodyPr wrap="square" anchor="ctr">
+            <a:spAutoFit/>
+          </a:bodyPr>
+          <a:lstStyle/>
+          <a:p>
+            <a:pPr algn="l">
+              <a:lnSpc>
+                <a:spcPct val="105000"/>
+              </a:lnSpc>
+            </a:pPr>
+            <a:r>
+              <a:rPr sz="1500" b="0" i="0">
+                <a:solidFill>
+                  <a:srgbClr val="6B665C"/>
+                </a:solidFill>
+                <a:latin typeface="Comic Sans MS"/>
+              </a:rPr>
+              <a:t>48% plan a skilliday — PwC · ADP · Mastercard</a:t>
+            </a:r>
+          </a:p>
+        </p:txBody>
+      </p:sp>
+      <p:sp>
+        <p:nvSpPr>
+          <p:cNvPr id="20" name="TextBox 19"/>
+          <p:cNvSpPr txBox="1"/>
+          <p:nvPr/>
+        </p:nvSpPr>
+        <p:spPr>
+          <a:xfrm>
+            <a:off x="685800" y="6126480"/>
+            <a:ext cx="10972800" cy="457200"/>
+          </a:xfrm>
+          <a:prstGeom prst="rect">
+            <a:avLst/>
+          </a:prstGeom>
+          <a:noFill/>
+        </p:spPr>
+        <p:txBody>
+          <a:bodyPr wrap="square" anchor="t">
+            <a:spAutoFit/>
+          </a:bodyPr>
+          <a:lstStyle/>
+          <a:p>
+            <a:pPr algn="l">
+              <a:lnSpc>
+                <a:spcPct val="105000"/>
+              </a:lnSpc>
+            </a:pPr>
+            <a:r>
+              <a:rPr sz="1400" b="0" i="1">
+                <a:solidFill>
+                  <a:srgbClr val="2EA05A"/>
+                </a:solidFill>
+                <a:latin typeface="Comic Sans MS"/>
+              </a:rPr>
+              <a:t>✅  If you read the 31 July Scoreboard, you are up to date. Nothing today changes the plan.</a:t>
             </a:r>
           </a:p>
         </p:txBody>
@@ -4340,13 +4227,13 @@
               </a:lnSpc>
             </a:pPr>
             <a:r>
-              <a:rPr sz="3400" b="1" i="0">
+              <a:rPr sz="3200" b="1" i="0">
                 <a:solidFill>
                   <a:srgbClr val="1D1D2B"/>
                 </a:solidFill>
                 <a:latin typeface="Comic Sans MS"/>
               </a:rPr>
-              <a:t>The doodle: the Anxiety Ladder</a:t>
+              <a:t>What moved in 24h: minor texture only</a:t>
             </a:r>
           </a:p>
         </p:txBody>
@@ -4360,7 +4247,7 @@
         <p:spPr>
           <a:xfrm>
             <a:off x="685800" y="1143000"/>
-            <a:ext cx="5120640" cy="109728"/>
+            <a:ext cx="5760720" cy="109728"/>
           </a:xfrm>
           <a:prstGeom prst="roundRect">
             <a:avLst/>
@@ -4406,7 +4293,7 @@
         <p:spPr>
           <a:xfrm>
             <a:off x="685800" y="1325880"/>
-            <a:ext cx="10881360" cy="548640"/>
+            <a:ext cx="10881360" cy="502920"/>
           </a:xfrm>
           <a:prstGeom prst="rect">
             <a:avLst/>
@@ -4425,13 +4312,13 @@
               </a:lnSpc>
             </a:pPr>
             <a:r>
-              <a:rPr sz="1700" b="0" i="1">
+              <a:rPr sz="1600" b="0" i="1">
                 <a:solidFill>
                   <a:srgbClr val="6B665C"/>
                 </a:solidFill>
                 <a:latin typeface="Comic Sans MS"/>
               </a:rPr>
-              <a:t>"Only 22% feel safe" hid a gradient. The newest ADP cut, by rung:</a:t>
+              <a:t>No new flagship report. One detail worth logging: the "22% feel safe" number is a ladder.</a:t>
             </a:r>
           </a:p>
         </p:txBody>
@@ -4444,8 +4331,8 @@
         </p:nvSpPr>
         <p:spPr>
           <a:xfrm>
-            <a:off x="548640" y="2130552"/>
-            <a:ext cx="3200400" cy="548640"/>
+            <a:off x="548640" y="2084831"/>
+            <a:ext cx="3200400" cy="502920"/>
           </a:xfrm>
           <a:prstGeom prst="rect">
             <a:avLst/>
@@ -4464,7 +4351,7 @@
               </a:lnSpc>
             </a:pPr>
             <a:r>
-              <a:rPr sz="1700" b="1" i="0">
+              <a:rPr sz="1600" b="1" i="0">
                 <a:solidFill>
                   <a:srgbClr val="1D1D2B"/>
                 </a:solidFill>
@@ -4483,8 +4370,8 @@
         </p:nvSpPr>
         <p:spPr>
           <a:xfrm>
-            <a:off x="3931920" y="2148840"/>
-            <a:ext cx="6126480" cy="502920"/>
+            <a:off x="3931920" y="2103120"/>
+            <a:ext cx="6035040" cy="457200"/>
           </a:xfrm>
           <a:prstGeom prst="roundRect">
             <a:avLst/>
@@ -4529,8 +4416,8 @@
         </p:nvSpPr>
         <p:spPr>
           <a:xfrm>
-            <a:off x="10195560" y="2130552"/>
-            <a:ext cx="1280160" cy="548640"/>
+            <a:off x="10104119" y="2084831"/>
+            <a:ext cx="1280160" cy="502920"/>
           </a:xfrm>
           <a:prstGeom prst="rect">
             <a:avLst/>
@@ -4549,7 +4436,7 @@
               </a:lnSpc>
             </a:pPr>
             <a:r>
-              <a:rPr sz="1800" b="1" i="0">
+              <a:rPr sz="1700" b="1" i="0">
                 <a:solidFill>
                   <a:srgbClr val="2EA05A"/>
                 </a:solidFill>
@@ -4568,8 +4455,8 @@
         </p:nvSpPr>
         <p:spPr>
           <a:xfrm>
-            <a:off x="548640" y="2843784"/>
-            <a:ext cx="3200400" cy="548640"/>
+            <a:off x="548640" y="2743199"/>
+            <a:ext cx="3200400" cy="502920"/>
           </a:xfrm>
           <a:prstGeom prst="rect">
             <a:avLst/>
@@ -4588,7 +4475,7 @@
               </a:lnSpc>
             </a:pPr>
             <a:r>
-              <a:rPr sz="1700" b="1" i="0">
+              <a:rPr sz="1600" b="1" i="0">
                 <a:solidFill>
                   <a:srgbClr val="1D1D2B"/>
                 </a:solidFill>
@@ -4607,8 +4494,8 @@
         </p:nvSpPr>
         <p:spPr>
           <a:xfrm>
-            <a:off x="3931920" y="2862072"/>
-            <a:ext cx="5426310" cy="502920"/>
+            <a:off x="3931920" y="2761487"/>
+            <a:ext cx="5345321" cy="457200"/>
           </a:xfrm>
           <a:prstGeom prst="roundRect">
             <a:avLst/>
@@ -4653,8 +4540,8 @@
         </p:nvSpPr>
         <p:spPr>
           <a:xfrm>
-            <a:off x="9495390" y="2843784"/>
-            <a:ext cx="1280160" cy="548640"/>
+            <a:off x="9414401" y="2743199"/>
+            <a:ext cx="1280160" cy="502920"/>
           </a:xfrm>
           <a:prstGeom prst="rect">
             <a:avLst/>
@@ -4673,7 +4560,7 @@
               </a:lnSpc>
             </a:pPr>
             <a:r>
-              <a:rPr sz="1800" b="1" i="0">
+              <a:rPr sz="1700" b="1" i="0">
                 <a:solidFill>
                   <a:srgbClr val="2EA05A"/>
                 </a:solidFill>
@@ -4692,8 +4579,8 @@
         </p:nvSpPr>
         <p:spPr>
           <a:xfrm>
-            <a:off x="548640" y="3557016"/>
-            <a:ext cx="3200400" cy="548640"/>
+            <a:off x="548640" y="3401568"/>
+            <a:ext cx="3200400" cy="502920"/>
           </a:xfrm>
           <a:prstGeom prst="rect">
             <a:avLst/>
@@ -4712,7 +4599,7 @@
               </a:lnSpc>
             </a:pPr>
             <a:r>
-              <a:rPr sz="1700" b="1" i="0">
+              <a:rPr sz="1600" b="1" i="0">
                 <a:solidFill>
                   <a:srgbClr val="1D1D2B"/>
                 </a:solidFill>
@@ -4731,8 +4618,8 @@
         </p:nvSpPr>
         <p:spPr>
           <a:xfrm>
-            <a:off x="3931920" y="3575304"/>
-            <a:ext cx="4025972" cy="502920"/>
+            <a:off x="3931920" y="3419856"/>
+            <a:ext cx="3965883" cy="457200"/>
           </a:xfrm>
           <a:prstGeom prst="roundRect">
             <a:avLst/>
@@ -4777,8 +4664,8 @@
         </p:nvSpPr>
         <p:spPr>
           <a:xfrm>
-            <a:off x="8095052" y="3557016"/>
-            <a:ext cx="1280160" cy="548640"/>
+            <a:off x="8034963" y="3401568"/>
+            <a:ext cx="1280160" cy="502920"/>
           </a:xfrm>
           <a:prstGeom prst="rect">
             <a:avLst/>
@@ -4797,7 +4684,7 @@
               </a:lnSpc>
             </a:pPr>
             <a:r>
-              <a:rPr sz="1800" b="1" i="0">
+              <a:rPr sz="1700" b="1" i="0">
                 <a:solidFill>
                   <a:srgbClr val="2E6BE8"/>
                 </a:solidFill>
@@ -4816,8 +4703,8 @@
         </p:nvSpPr>
         <p:spPr>
           <a:xfrm>
-            <a:off x="548640" y="4270248"/>
-            <a:ext cx="3200400" cy="548640"/>
+            <a:off x="548640" y="4059936"/>
+            <a:ext cx="3200400" cy="502920"/>
           </a:xfrm>
           <a:prstGeom prst="rect">
             <a:avLst/>
@@ -4836,7 +4723,7 @@
               </a:lnSpc>
             </a:pPr>
             <a:r>
-              <a:rPr sz="1700" b="1" i="0">
+              <a:rPr sz="1600" b="1" i="0">
                 <a:solidFill>
                   <a:srgbClr val="1D1D2B"/>
                 </a:solidFill>
@@ -4855,8 +4742,8 @@
         </p:nvSpPr>
         <p:spPr>
           <a:xfrm>
-            <a:off x="3931920" y="4288536"/>
-            <a:ext cx="3675888" cy="502920"/>
+            <a:off x="3931920" y="4078224"/>
+            <a:ext cx="3621024" cy="457200"/>
           </a:xfrm>
           <a:prstGeom prst="roundRect">
             <a:avLst/>
@@ -4901,8 +4788,8 @@
         </p:nvSpPr>
         <p:spPr>
           <a:xfrm>
-            <a:off x="7744968" y="4270248"/>
-            <a:ext cx="1280160" cy="548640"/>
+            <a:off x="7690104" y="4059936"/>
+            <a:ext cx="1280160" cy="502920"/>
           </a:xfrm>
           <a:prstGeom prst="rect">
             <a:avLst/>
@@ -4921,7 +4808,7 @@
               </a:lnSpc>
             </a:pPr>
             <a:r>
-              <a:rPr sz="1800" b="1" i="0">
+              <a:rPr sz="1700" b="1" i="0">
                 <a:solidFill>
                   <a:srgbClr val="E85D2E"/>
                 </a:solidFill>
@@ -4940,8 +4827,8 @@
         </p:nvSpPr>
         <p:spPr>
           <a:xfrm>
-            <a:off x="548640" y="4983480"/>
-            <a:ext cx="3200400" cy="548640"/>
+            <a:off x="548640" y="4718304"/>
+            <a:ext cx="3200400" cy="502920"/>
           </a:xfrm>
           <a:prstGeom prst="rect">
             <a:avLst/>
@@ -4960,7 +4847,7 @@
               </a:lnSpc>
             </a:pPr>
             <a:r>
-              <a:rPr sz="1700" b="1" i="0">
+              <a:rPr sz="1600" b="1" i="0">
                 <a:solidFill>
                   <a:srgbClr val="1D1D2B"/>
                 </a:solidFill>
@@ -4979,8 +4866,8 @@
         </p:nvSpPr>
         <p:spPr>
           <a:xfrm>
-            <a:off x="3931920" y="5001768"/>
-            <a:ext cx="3150761" cy="502920"/>
+            <a:off x="3931920" y="4736592"/>
+            <a:ext cx="3103734" cy="457200"/>
           </a:xfrm>
           <a:prstGeom prst="roundRect">
             <a:avLst/>
@@ -5025,8 +4912,8 @@
         </p:nvSpPr>
         <p:spPr>
           <a:xfrm>
-            <a:off x="7219841" y="4983480"/>
-            <a:ext cx="1280160" cy="548640"/>
+            <a:off x="7172814" y="4718304"/>
+            <a:ext cx="1280160" cy="502920"/>
           </a:xfrm>
           <a:prstGeom prst="rect">
             <a:avLst/>
@@ -5045,7 +4932,7 @@
               </a:lnSpc>
             </a:pPr>
             <a:r>
-              <a:rPr sz="1800" b="1" i="0">
+              <a:rPr sz="1700" b="1" i="0">
                 <a:solidFill>
                   <a:srgbClr val="E85D2E"/>
                 </a:solidFill>
@@ -5064,8 +4951,8 @@
         </p:nvSpPr>
         <p:spPr>
           <a:xfrm>
-            <a:off x="548640" y="5806440"/>
-            <a:ext cx="10972800" cy="822960"/>
+            <a:off x="548640" y="5532120"/>
+            <a:ext cx="10972800" cy="1005840"/>
           </a:xfrm>
           <a:prstGeom prst="rect">
             <a:avLst/>
@@ -5090,7 +4977,7 @@
                 </a:solidFill>
                 <a:latin typeface="Comic Sans MS"/>
               </a:rPr>
-              <a:t>The higher you sit, the safer you feel — a ~17-point gap. Anxiety concentrates exactly</a:t>
+              <a:t>Not new data — a finer cut of the same ADP survey. But it's the year in one shape:</a:t>
             </a:r>
           </a:p>
           <a:p>
@@ -5106,7 +4993,23 @@
                 </a:solidFill>
                 <a:latin typeface="Comic Sans MS"/>
               </a:rPr>
-              <a:t>where the work is most routine. Closest to the task = bottom rung. Source: ADP Research.</a:t>
+              <a:t>anxiety concentrates where the work is most automatable — the same rung Stanford's −13%</a:t>
+            </a:r>
+          </a:p>
+          <a:p>
+            <a:pPr algn="l">
+              <a:lnSpc>
+                <a:spcPct val="105000"/>
+              </a:lnSpc>
+            </a:pPr>
+            <a:r>
+              <a:rPr sz="1400" b="0" i="1">
+                <a:solidFill>
+                  <a:srgbClr val="6B665C"/>
+                </a:solidFill>
+                <a:latin typeface="Comic Sans MS"/>
+              </a:rPr>
+              <a:t>payroll data shows actually shrinking. (Also, by role: researchers 51% anxious vs founders 15%.)</a:t>
             </a:r>
           </a:p>
         </p:txBody>
@@ -5139,55 +5042,16 @@
       <p:grpSpPr/>
       <p:sp>
         <p:nvSpPr>
-          <p:cNvPr id="2" name="TextBox 1"/>
-          <p:cNvSpPr txBox="1"/>
-          <p:nvPr/>
-        </p:nvSpPr>
-        <p:spPr>
-          <a:xfrm>
-            <a:off x="640080" y="365760"/>
-            <a:ext cx="10972800" cy="822960"/>
-          </a:xfrm>
-          <a:prstGeom prst="rect">
-            <a:avLst/>
-          </a:prstGeom>
-          <a:noFill/>
-        </p:spPr>
-        <p:txBody>
-          <a:bodyPr wrap="square" anchor="t">
-            <a:spAutoFit/>
-          </a:bodyPr>
-          <a:lstStyle/>
-          <a:p>
-            <a:pPr algn="l">
-              <a:lnSpc>
-                <a:spcPct val="105000"/>
-              </a:lnSpc>
-            </a:pPr>
-            <a:r>
-              <a:rPr sz="3200" b="1" i="0">
-                <a:solidFill>
-                  <a:srgbClr val="1D1D2B"/>
-                </a:solidFill>
-                <a:latin typeface="Comic Sans MS"/>
-              </a:rPr>
-              <a:t>Three genuinely-new signals since July</a:t>
-            </a:r>
-          </a:p>
-        </p:txBody>
-      </p:sp>
-      <p:sp>
-        <p:nvSpPr>
-          <p:cNvPr id="3" name="Rounded Rectangle 2"/>
+          <p:cNvPr id="2" name="Rectangle 1"/>
           <p:cNvSpPr/>
           <p:nvPr/>
         </p:nvSpPr>
         <p:spPr>
           <a:xfrm>
-            <a:off x="685800" y="1143000"/>
-            <a:ext cx="6035040" cy="109728"/>
-          </a:xfrm>
-          <a:prstGeom prst="roundRect">
+            <a:off x="0" y="0"/>
+            <a:ext cx="12191695" cy="256032"/>
+          </a:xfrm>
+          <a:prstGeom prst="rect">
             <a:avLst/>
           </a:prstGeom>
           <a:solidFill>
@@ -5224,22 +5088,63 @@
       </p:sp>
       <p:sp>
         <p:nvSpPr>
+          <p:cNvPr id="3" name="TextBox 2"/>
+          <p:cNvSpPr txBox="1"/>
+          <p:nvPr/>
+        </p:nvSpPr>
+        <p:spPr>
+          <a:xfrm>
+            <a:off x="640080" y="457200"/>
+            <a:ext cx="10972800" cy="822960"/>
+          </a:xfrm>
+          <a:prstGeom prst="rect">
+            <a:avLst/>
+          </a:prstGeom>
+          <a:noFill/>
+        </p:spPr>
+        <p:txBody>
+          <a:bodyPr wrap="square" anchor="t">
+            <a:spAutoFit/>
+          </a:bodyPr>
+          <a:lstStyle/>
+          <a:p>
+            <a:pPr algn="l">
+              <a:lnSpc>
+                <a:spcPct val="105000"/>
+              </a:lnSpc>
+            </a:pPr>
+            <a:r>
+              <a:rPr sz="3400" b="1" i="0">
+                <a:solidFill>
+                  <a:srgbClr val="1D1D2B"/>
+                </a:solidFill>
+                <a:latin typeface="Comic Sans MS"/>
+              </a:rPr>
+              <a:t>🛠  The tool: the Judgment Journal</a:t>
+            </a:r>
+          </a:p>
+        </p:txBody>
+      </p:sp>
+      <p:sp>
+        <p:nvSpPr>
           <p:cNvPr id="4" name="Rounded Rectangle 3"/>
           <p:cNvSpPr/>
           <p:nvPr/>
         </p:nvSpPr>
         <p:spPr>
           <a:xfrm>
-            <a:off x="685800" y="1828800"/>
-            <a:ext cx="3520440" cy="4023360"/>
+            <a:off x="685800" y="1280160"/>
+            <a:ext cx="6217920" cy="109728"/>
           </a:xfrm>
           <a:prstGeom prst="roundRect">
             <a:avLst/>
           </a:prstGeom>
-          <a:noFill/>
-          <a:ln w="31750">
+          <a:solidFill>
+            <a:srgbClr val="2E6BE8"/>
+          </a:solidFill>
+          <a:ln w="6350">
             <a:solidFill>
-              <a:srgbClr val="E85D2E"/>
+              <a:srgbClr val="2E6BE8"/>
             </a:solidFill>
           </a:ln>
           <a:effectLst/>
@@ -5274,8 +5179,8 @@
         </p:nvSpPr>
         <p:spPr>
           <a:xfrm>
-            <a:off x="914400" y="2011680"/>
-            <a:ext cx="3063240" cy="822960"/>
+            <a:off x="685800" y="1463040"/>
+            <a:ext cx="10881360" cy="640080"/>
           </a:xfrm>
           <a:prstGeom prst="rect">
             <a:avLst/>
@@ -5294,138 +5199,35 @@
               </a:lnSpc>
             </a:pPr>
             <a:r>
-              <a:rPr sz="1700" b="1" i="0">
-                <a:solidFill>
-                  <a:srgbClr val="E85D2E"/>
+              <a:rPr sz="1700" b="0" i="1">
+                <a:solidFill>
+                  <a:srgbClr val="1D1D2B"/>
                 </a:solidFill>
                 <a:latin typeface="Comic Sans MS"/>
               </a:rPr>
-              <a:t>1 · ANXIETY BY ROLE</a:t>
-            </a:r>
-          </a:p>
-        </p:txBody>
-      </p:sp>
-      <p:sp>
-        <p:nvSpPr>
-          <p:cNvPr id="6" name="TextBox 5"/>
-          <p:cNvSpPr txBox="1"/>
-          <p:nvPr/>
-        </p:nvSpPr>
-        <p:spPr>
-          <a:xfrm>
-            <a:off x="914400" y="2788920"/>
-            <a:ext cx="3063240" cy="3017520"/>
-          </a:xfrm>
-          <a:prstGeom prst="rect">
-            <a:avLst/>
-          </a:prstGeom>
-          <a:noFill/>
-        </p:spPr>
-        <p:txBody>
-          <a:bodyPr wrap="square" anchor="t">
-            <a:spAutoFit/>
-          </a:bodyPr>
-          <a:lstStyle/>
-          <a:p>
-            <a:pPr algn="l">
-              <a:lnSpc>
-                <a:spcPct val="110000"/>
-              </a:lnSpc>
-            </a:pPr>
-            <a:r>
-              <a:rPr sz="1500" b="0" i="0">
-                <a:solidFill>
-                  <a:srgbClr val="1D1D2B"/>
-                </a:solidFill>
-                <a:latin typeface="Comic Sans MS"/>
-              </a:rPr>
-              <a:t>Not just seniority. Researchers 51%</a:t>
-            </a:r>
-          </a:p>
-          <a:p>
-            <a:pPr algn="l">
-              <a:lnSpc>
-                <a:spcPct val="110000"/>
-              </a:lnSpc>
-            </a:pPr>
-            <a:r>
-              <a:rPr sz="1500" b="0" i="0">
-                <a:solidFill>
-                  <a:srgbClr val="1D1D2B"/>
-                </a:solidFill>
-                <a:latin typeface="Comic Sans MS"/>
-              </a:rPr>
-              <a:t>anxious vs founders 15%. Designers</a:t>
-            </a:r>
-          </a:p>
-          <a:p>
-            <a:pPr algn="l">
-              <a:lnSpc>
-                <a:spcPct val="110000"/>
-              </a:lnSpc>
-            </a:pPr>
-            <a:r>
-              <a:rPr sz="1500" b="0" i="0">
-                <a:solidFill>
-                  <a:srgbClr val="1D1D2B"/>
-                </a:solidFill>
-                <a:latin typeface="Comic Sans MS"/>
-              </a:rPr>
-              <a:t>63% overwhelmed, 61% tired — highest</a:t>
-            </a:r>
-          </a:p>
-          <a:p>
-            <a:pPr algn="l">
-              <a:lnSpc>
-                <a:spcPct val="110000"/>
-              </a:lnSpc>
-            </a:pPr>
-            <a:r>
-              <a:rPr sz="1500" b="0" i="0">
-                <a:solidFill>
-                  <a:srgbClr val="1D1D2B"/>
-                </a:solidFill>
-                <a:latin typeface="Comic Sans MS"/>
-              </a:rPr>
-              <a:t>of any role. Exposure is uneven inside</a:t>
-            </a:r>
-          </a:p>
-          <a:p>
-            <a:pPr algn="l">
-              <a:lnSpc>
-                <a:spcPct val="110000"/>
-              </a:lnSpc>
-            </a:pPr>
-            <a:r>
-              <a:rPr sz="1500" b="0" i="0">
-                <a:solidFill>
-                  <a:srgbClr val="1D1D2B"/>
-                </a:solidFill>
-                <a:latin typeface="Comic Sans MS"/>
-              </a:rPr>
-              <a:t>the same company.</a:t>
-            </a:r>
-          </a:p>
-        </p:txBody>
-      </p:sp>
-      <p:sp>
-        <p:nvSpPr>
-          <p:cNvPr id="7" name="Rounded Rectangle 6"/>
+              <a:t>Pairs with last week's Reskill Ledger. Gartner says half of orgs will soon test if you can think WITHOUT AI.</a:t>
+            </a:r>
+          </a:p>
+        </p:txBody>
+      </p:sp>
+      <p:sp>
+        <p:nvSpPr>
+          <p:cNvPr id="6" name="Rounded Rectangle 5"/>
           <p:cNvSpPr/>
           <p:nvPr/>
         </p:nvSpPr>
         <p:spPr>
           <a:xfrm>
-            <a:off x="4526280" y="1828800"/>
-            <a:ext cx="3520440" cy="4023360"/>
+            <a:off x="1097280" y="2468880"/>
+            <a:ext cx="2834640" cy="640080"/>
           </a:xfrm>
           <a:prstGeom prst="roundRect">
             <a:avLst/>
           </a:prstGeom>
           <a:noFill/>
-          <a:ln w="31750">
+          <a:ln w="25400">
             <a:solidFill>
-              <a:srgbClr val="2EA05A"/>
+              <a:srgbClr val="E85D2E"/>
             </a:solidFill>
           </a:ln>
           <a:effectLst/>
@@ -5454,14 +5256,53 @@
       </p:sp>
       <p:sp>
         <p:nvSpPr>
+          <p:cNvPr id="7" name="TextBox 6"/>
+          <p:cNvSpPr txBox="1"/>
+          <p:nvPr/>
+        </p:nvSpPr>
+        <p:spPr>
+          <a:xfrm>
+            <a:off x="1097280" y="2523744"/>
+            <a:ext cx="2834640" cy="548640"/>
+          </a:xfrm>
+          <a:prstGeom prst="rect">
+            <a:avLst/>
+          </a:prstGeom>
+          <a:noFill/>
+        </p:spPr>
+        <p:txBody>
+          <a:bodyPr wrap="square" anchor="t">
+            <a:spAutoFit/>
+          </a:bodyPr>
+          <a:lstStyle/>
+          <a:p>
+            <a:pPr algn="ctr">
+              <a:lnSpc>
+                <a:spcPct val="105000"/>
+              </a:lnSpc>
+            </a:pPr>
+            <a:r>
+              <a:rPr sz="1800" b="1" i="0">
+                <a:solidFill>
+                  <a:srgbClr val="E85D2E"/>
+                </a:solidFill>
+                <a:latin typeface="Comic Sans MS"/>
+              </a:rPr>
+              <a:t>1 · CAUGHT IT</a:t>
+            </a:r>
+          </a:p>
+        </p:txBody>
+      </p:sp>
+      <p:sp>
+        <p:nvSpPr>
           <p:cNvPr id="8" name="TextBox 7"/>
           <p:cNvSpPr txBox="1"/>
           <p:nvPr/>
         </p:nvSpPr>
         <p:spPr>
           <a:xfrm>
-            <a:off x="4754880" y="2011680"/>
-            <a:ext cx="3063240" cy="822960"/>
+            <a:off x="4206240" y="2468880"/>
+            <a:ext cx="6858000" cy="640080"/>
           </a:xfrm>
           <a:prstGeom prst="rect">
             <a:avLst/>
@@ -5469,7 +5310,7 @@
           <a:noFill/>
         </p:spPr>
         <p:txBody>
-          <a:bodyPr wrap="square" anchor="t">
+          <a:bodyPr wrap="square" anchor="ctr">
             <a:spAutoFit/>
           </a:bodyPr>
           <a:lstStyle/>
@@ -5480,136 +5321,33 @@
               </a:lnSpc>
             </a:pPr>
             <a:r>
-              <a:rPr sz="1700" b="1" i="0">
-                <a:solidFill>
-                  <a:srgbClr val="2EA05A"/>
+              <a:rPr sz="1700" b="0" i="0">
+                <a:solidFill>
+                  <a:srgbClr val="1D1D2B"/>
                 </a:solidFill>
                 <a:latin typeface="Comic Sans MS"/>
               </a:rPr>
-              <a:t>2 · LEARNING GOES SOCIAL</a:t>
-            </a:r>
-          </a:p>
-        </p:txBody>
-      </p:sp>
-      <p:sp>
-        <p:nvSpPr>
-          <p:cNvPr id="9" name="TextBox 8"/>
-          <p:cNvSpPr txBox="1"/>
-          <p:nvPr/>
-        </p:nvSpPr>
-        <p:spPr>
-          <a:xfrm>
-            <a:off x="4754880" y="2788920"/>
-            <a:ext cx="3063240" cy="3017520"/>
-          </a:xfrm>
-          <a:prstGeom prst="rect">
-            <a:avLst/>
-          </a:prstGeom>
-          <a:noFill/>
-        </p:spPr>
-        <p:txBody>
-          <a:bodyPr wrap="square" anchor="t">
-            <a:spAutoFit/>
-          </a:bodyPr>
-          <a:lstStyle/>
-          <a:p>
-            <a:pPr algn="l">
-              <a:lnSpc>
-                <a:spcPct val="110000"/>
-              </a:lnSpc>
-            </a:pPr>
-            <a:r>
-              <a:rPr sz="1500" b="0" i="0">
-                <a:solidFill>
-                  <a:srgbClr val="1D1D2B"/>
-                </a:solidFill>
-                <a:latin typeface="Comic Sans MS"/>
-              </a:rPr>
-              <a:t>"Festivalization of wellness" — raves,</a:t>
-            </a:r>
-          </a:p>
-          <a:p>
-            <a:pPr algn="l">
-              <a:lnSpc>
-                <a:spcPct val="110000"/>
-              </a:lnSpc>
-            </a:pPr>
-            <a:r>
-              <a:rPr sz="1500" b="0" i="0">
-                <a:solidFill>
-                  <a:srgbClr val="1D1D2B"/>
-                </a:solidFill>
-                <a:latin typeface="Comic Sans MS"/>
-              </a:rPr>
-              <a:t>multi-day group immersions. The</a:t>
-            </a:r>
-          </a:p>
-          <a:p>
-            <a:pPr algn="l">
-              <a:lnSpc>
-                <a:spcPct val="110000"/>
-              </a:lnSpc>
-            </a:pPr>
-            <a:r>
-              <a:rPr sz="1500" b="0" i="0">
-                <a:solidFill>
-                  <a:srgbClr val="1D1D2B"/>
-                </a:solidFill>
-                <a:latin typeface="Comic Sans MS"/>
-              </a:rPr>
-              <a:t>skilliday turns communal &amp; identity-</a:t>
-            </a:r>
-          </a:p>
-          <a:p>
-            <a:pPr algn="l">
-              <a:lnSpc>
-                <a:spcPct val="110000"/>
-              </a:lnSpc>
-            </a:pPr>
-            <a:r>
-              <a:rPr sz="1500" b="0" i="0">
-                <a:solidFill>
-                  <a:srgbClr val="1D1D2B"/>
-                </a:solidFill>
-                <a:latin typeface="Comic Sans MS"/>
-              </a:rPr>
-              <a:t>driven. We crave the embodied things</a:t>
-            </a:r>
-          </a:p>
-          <a:p>
-            <a:pPr algn="l">
-              <a:lnSpc>
-                <a:spcPct val="110000"/>
-              </a:lnSpc>
-            </a:pPr>
-            <a:r>
-              <a:rPr sz="1500" b="0" i="0">
-                <a:solidFill>
-                  <a:srgbClr val="1D1D2B"/>
-                </a:solidFill>
-                <a:latin typeface="Comic Sans MS"/>
-              </a:rPr>
-              <a:t>AI can't do — with other humans.</a:t>
-            </a:r>
-          </a:p>
-        </p:txBody>
-      </p:sp>
-      <p:sp>
-        <p:nvSpPr>
-          <p:cNvPr id="10" name="Rounded Rectangle 9"/>
+              <a:t>One thing AI got wrong this week that I caught &amp; fixed.</a:t>
+            </a:r>
+          </a:p>
+        </p:txBody>
+      </p:sp>
+      <p:sp>
+        <p:nvSpPr>
+          <p:cNvPr id="9" name="Rounded Rectangle 8"/>
           <p:cNvSpPr/>
           <p:nvPr/>
         </p:nvSpPr>
         <p:spPr>
           <a:xfrm>
-            <a:off x="8366760" y="1828800"/>
-            <a:ext cx="3520440" cy="4023360"/>
+            <a:off x="1097280" y="3337560"/>
+            <a:ext cx="2834640" cy="640080"/>
           </a:xfrm>
           <a:prstGeom prst="roundRect">
             <a:avLst/>
           </a:prstGeom>
           <a:noFill/>
-          <a:ln w="31750">
+          <a:ln w="25400">
             <a:solidFill>
               <a:srgbClr val="2E6BE8"/>
             </a:solidFill>
@@ -5640,14 +5378,53 @@
       </p:sp>
       <p:sp>
         <p:nvSpPr>
+          <p:cNvPr id="10" name="TextBox 9"/>
+          <p:cNvSpPr txBox="1"/>
+          <p:nvPr/>
+        </p:nvSpPr>
+        <p:spPr>
+          <a:xfrm>
+            <a:off x="1097280" y="3392424"/>
+            <a:ext cx="2834640" cy="548640"/>
+          </a:xfrm>
+          <a:prstGeom prst="rect">
+            <a:avLst/>
+          </a:prstGeom>
+          <a:noFill/>
+        </p:spPr>
+        <p:txBody>
+          <a:bodyPr wrap="square" anchor="t">
+            <a:spAutoFit/>
+          </a:bodyPr>
+          <a:lstStyle/>
+          <a:p>
+            <a:pPr algn="ctr">
+              <a:lnSpc>
+                <a:spcPct val="105000"/>
+              </a:lnSpc>
+            </a:pPr>
+            <a:r>
+              <a:rPr sz="1800" b="1" i="0">
+                <a:solidFill>
+                  <a:srgbClr val="2E6BE8"/>
+                </a:solidFill>
+                <a:latin typeface="Comic Sans MS"/>
+              </a:rPr>
+              <a:t>2 · OVERRODE</a:t>
+            </a:r>
+          </a:p>
+        </p:txBody>
+      </p:sp>
+      <p:sp>
+        <p:nvSpPr>
           <p:cNvPr id="11" name="TextBox 10"/>
           <p:cNvSpPr txBox="1"/>
           <p:nvPr/>
         </p:nvSpPr>
         <p:spPr>
           <a:xfrm>
-            <a:off x="8595360" y="2011680"/>
-            <a:ext cx="3063240" cy="822960"/>
+            <a:off x="4206240" y="3337560"/>
+            <a:ext cx="6858000" cy="640080"/>
           </a:xfrm>
           <a:prstGeom prst="rect">
             <a:avLst/>
@@ -5655,7 +5432,7 @@
           <a:noFill/>
         </p:spPr>
         <p:txBody>
-          <a:bodyPr wrap="square" anchor="t">
+          <a:bodyPr wrap="square" anchor="ctr">
             <a:spAutoFit/>
           </a:bodyPr>
           <a:lstStyle/>
@@ -5666,205 +5443,35 @@
               </a:lnSpc>
             </a:pPr>
             <a:r>
-              <a:rPr sz="1700" b="1" i="0">
-                <a:solidFill>
-                  <a:srgbClr val="2E6BE8"/>
+              <a:rPr sz="1700" b="0" i="0">
+                <a:solidFill>
+                  <a:srgbClr val="1D1D2B"/>
                 </a:solidFill>
                 <a:latin typeface="Comic Sans MS"/>
               </a:rPr>
-              <a:t>3 · GAP PRICED AS MACRO</a:t>
-            </a:r>
-          </a:p>
-        </p:txBody>
-      </p:sp>
-      <p:sp>
-        <p:nvSpPr>
-          <p:cNvPr id="12" name="TextBox 11"/>
-          <p:cNvSpPr txBox="1"/>
-          <p:nvPr/>
-        </p:nvSpPr>
-        <p:spPr>
-          <a:xfrm>
-            <a:off x="8595360" y="2788920"/>
-            <a:ext cx="3063240" cy="3017520"/>
-          </a:xfrm>
-          <a:prstGeom prst="rect">
-            <a:avLst/>
-          </a:prstGeom>
-          <a:noFill/>
-        </p:spPr>
-        <p:txBody>
-          <a:bodyPr wrap="square" anchor="t">
-            <a:spAutoFit/>
-          </a:bodyPr>
-          <a:lstStyle/>
-          <a:p>
-            <a:pPr algn="l">
-              <a:lnSpc>
-                <a:spcPct val="110000"/>
-              </a:lnSpc>
-            </a:pPr>
-            <a:r>
-              <a:rPr sz="1500" b="0" i="0">
-                <a:solidFill>
-                  <a:srgbClr val="1D1D2B"/>
-                </a:solidFill>
-                <a:latin typeface="Comic Sans MS"/>
-              </a:rPr>
-              <a:t>A ~$5.5T skills-gap price tag is doing</a:t>
-            </a:r>
-          </a:p>
-          <a:p>
-            <a:pPr algn="l">
-              <a:lnSpc>
-                <a:spcPct val="110000"/>
-              </a:lnSpc>
-            </a:pPr>
-            <a:r>
-              <a:rPr sz="1500" b="0" i="0">
-                <a:solidFill>
-                  <a:srgbClr val="1D1D2B"/>
-                </a:solidFill>
-                <a:latin typeface="Comic Sans MS"/>
-              </a:rPr>
-              <a:t>the rounds (advocacy — caution). But</a:t>
-            </a:r>
-          </a:p>
-          <a:p>
-            <a:pPr algn="l">
-              <a:lnSpc>
-                <a:spcPct val="110000"/>
-              </a:lnSpc>
-            </a:pPr>
-            <a:r>
-              <a:rPr sz="1500" b="0" i="0">
-                <a:solidFill>
-                  <a:srgbClr val="1D1D2B"/>
-                </a:solidFill>
-                <a:latin typeface="Comic Sans MS"/>
-              </a:rPr>
-              <a:t>it matches verified data: 85% of hiring</a:t>
-            </a:r>
-          </a:p>
-          <a:p>
-            <a:pPr algn="l">
-              <a:lnSpc>
-                <a:spcPct val="110000"/>
-              </a:lnSpc>
-            </a:pPr>
-            <a:r>
-              <a:rPr sz="1500" b="0" i="0">
-                <a:solidFill>
-                  <a:srgbClr val="1D1D2B"/>
-                </a:solidFill>
-                <a:latin typeface="Comic Sans MS"/>
-              </a:rPr>
-              <a:t>mgrs are positive yet name skill gaps</a:t>
-            </a:r>
-          </a:p>
-          <a:p>
-            <a:pPr algn="l">
-              <a:lnSpc>
-                <a:spcPct val="110000"/>
-              </a:lnSpc>
-            </a:pPr>
-            <a:r>
-              <a:rPr sz="1500" b="0" i="0">
-                <a:solidFill>
-                  <a:srgbClr val="1D1D2B"/>
-                </a:solidFill>
-                <a:latin typeface="Comic Sans MS"/>
-              </a:rPr>
-              <a:t>as their #1 problem.</a:t>
-            </a:r>
-          </a:p>
-        </p:txBody>
-      </p:sp>
-      <p:sp>
-        <p:nvSpPr>
-          <p:cNvPr id="13" name="TextBox 12"/>
-          <p:cNvSpPr txBox="1"/>
-          <p:nvPr/>
-        </p:nvSpPr>
-        <p:spPr>
-          <a:xfrm>
-            <a:off x="685800" y="6126480"/>
-            <a:ext cx="10972800" cy="457200"/>
-          </a:xfrm>
-          <a:prstGeom prst="rect">
-            <a:avLst/>
-          </a:prstGeom>
-          <a:noFill/>
-        </p:spPr>
-        <p:txBody>
-          <a:bodyPr wrap="square" anchor="t">
-            <a:spAutoFit/>
-          </a:bodyPr>
-          <a:lstStyle/>
-          <a:p>
-            <a:pPr algn="l">
-              <a:lnSpc>
-                <a:spcPct val="105000"/>
-              </a:lnSpc>
-            </a:pPr>
-            <a:r>
-              <a:rPr sz="1200" b="0" i="1">
-                <a:solidFill>
-                  <a:srgbClr val="6B665C"/>
-                </a:solidFill>
-                <a:latin typeface="Comic Sans MS"/>
-              </a:rPr>
-              <a:t>Sources: ADP · Lenny's Newsletter (directional) · Global Wellness Summit 2026 · iternal.ai (caveated)</a:t>
-            </a:r>
-          </a:p>
-        </p:txBody>
-      </p:sp>
-    </p:spTree>
-  </p:cSld>
-  <p:clrMapOvr>
-    <a:masterClrMapping/>
-  </p:clrMapOvr>
-</p:sld>
-</file>
-
-<file path=ppt/slides/slide5.xml><?xml version="1.0" encoding="utf-8"?>
-<p:sld xmlns:a="http://schemas.openxmlformats.org/drawingml/2006/main" xmlns:p="http://schemas.openxmlformats.org/presentationml/2006/main" xmlns:r="http://schemas.openxmlformats.org/officeDocument/2006/relationships">
-  <p:cSld>
-    <p:bg>
-      <p:bgPr>
-        <a:solidFill>
-          <a:srgbClr val="FBF7EE"/>
-        </a:solidFill>
-        <a:effectLst/>
-      </p:bgPr>
-    </p:bg>
-    <p:spTree>
-      <p:nvGrpSpPr>
-        <p:cNvPr id="1" name=""/>
-        <p:cNvGrpSpPr/>
-        <p:nvPr/>
-      </p:nvGrpSpPr>
-      <p:grpSpPr/>
-      <p:sp>
-        <p:nvSpPr>
-          <p:cNvPr id="2" name="Rectangle 1"/>
+              <a:t>One time I chose against the AI's suggestion — and why.</a:t>
+            </a:r>
+          </a:p>
+        </p:txBody>
+      </p:sp>
+      <p:sp>
+        <p:nvSpPr>
+          <p:cNvPr id="12" name="Rounded Rectangle 11"/>
           <p:cNvSpPr/>
           <p:nvPr/>
         </p:nvSpPr>
         <p:spPr>
           <a:xfrm>
-            <a:off x="0" y="0"/>
-            <a:ext cx="12191695" cy="256032"/>
-          </a:xfrm>
-          <a:prstGeom prst="rect">
-            <a:avLst/>
-          </a:prstGeom>
-          <a:solidFill>
-            <a:srgbClr val="2E6BE8"/>
-          </a:solidFill>
-          <a:ln w="6350">
+            <a:off x="1097280" y="4206240"/>
+            <a:ext cx="2834640" cy="640080"/>
+          </a:xfrm>
+          <a:prstGeom prst="roundRect">
+            <a:avLst/>
+          </a:prstGeom>
+          <a:noFill/>
+          <a:ln w="25400">
             <a:solidFill>
-              <a:srgbClr val="2E6BE8"/>
+              <a:srgbClr val="2EA05A"/>
             </a:solidFill>
           </a:ln>
           <a:effectLst/>
@@ -5893,418 +5500,6 @@
       </p:sp>
       <p:sp>
         <p:nvSpPr>
-          <p:cNvPr id="3" name="TextBox 2"/>
-          <p:cNvSpPr txBox="1"/>
-          <p:nvPr/>
-        </p:nvSpPr>
-        <p:spPr>
-          <a:xfrm>
-            <a:off x="640080" y="457200"/>
-            <a:ext cx="10972800" cy="822960"/>
-          </a:xfrm>
-          <a:prstGeom prst="rect">
-            <a:avLst/>
-          </a:prstGeom>
-          <a:noFill/>
-        </p:spPr>
-        <p:txBody>
-          <a:bodyPr wrap="square" anchor="t">
-            <a:spAutoFit/>
-          </a:bodyPr>
-          <a:lstStyle/>
-          <a:p>
-            <a:pPr algn="l">
-              <a:lnSpc>
-                <a:spcPct val="105000"/>
-              </a:lnSpc>
-            </a:pPr>
-            <a:r>
-              <a:rPr sz="3400" b="1" i="0">
-                <a:solidFill>
-                  <a:srgbClr val="1D1D2B"/>
-                </a:solidFill>
-                <a:latin typeface="Comic Sans MS"/>
-              </a:rPr>
-              <a:t>🛠  The tool: the Judgment Journal</a:t>
-            </a:r>
-          </a:p>
-        </p:txBody>
-      </p:sp>
-      <p:sp>
-        <p:nvSpPr>
-          <p:cNvPr id="4" name="Rounded Rectangle 3"/>
-          <p:cNvSpPr/>
-          <p:nvPr/>
-        </p:nvSpPr>
-        <p:spPr>
-          <a:xfrm>
-            <a:off x="685800" y="1280160"/>
-            <a:ext cx="6217920" cy="109728"/>
-          </a:xfrm>
-          <a:prstGeom prst="roundRect">
-            <a:avLst/>
-          </a:prstGeom>
-          <a:solidFill>
-            <a:srgbClr val="2E6BE8"/>
-          </a:solidFill>
-          <a:ln w="6350">
-            <a:solidFill>
-              <a:srgbClr val="2E6BE8"/>
-            </a:solidFill>
-          </a:ln>
-          <a:effectLst/>
-        </p:spPr>
-        <p:style>
-          <a:lnRef idx="1">
-            <a:schemeClr val="accent1"/>
-          </a:lnRef>
-          <a:fillRef idx="3">
-            <a:schemeClr val="accent1"/>
-          </a:fillRef>
-          <a:effectRef idx="2">
-            <a:schemeClr val="accent1"/>
-          </a:effectRef>
-          <a:fontRef idx="minor">
-            <a:schemeClr val="lt1"/>
-          </a:fontRef>
-        </p:style>
-        <p:txBody>
-          <a:bodyPr rtlCol="0" anchor="ctr"/>
-          <a:lstStyle/>
-          <a:p>
-            <a:pPr algn="ctr"/>
-          </a:p>
-        </p:txBody>
-      </p:sp>
-      <p:sp>
-        <p:nvSpPr>
-          <p:cNvPr id="5" name="TextBox 4"/>
-          <p:cNvSpPr txBox="1"/>
-          <p:nvPr/>
-        </p:nvSpPr>
-        <p:spPr>
-          <a:xfrm>
-            <a:off x="685800" y="1463040"/>
-            <a:ext cx="10881360" cy="640080"/>
-          </a:xfrm>
-          <a:prstGeom prst="rect">
-            <a:avLst/>
-          </a:prstGeom>
-          <a:noFill/>
-        </p:spPr>
-        <p:txBody>
-          <a:bodyPr wrap="square" anchor="t">
-            <a:spAutoFit/>
-          </a:bodyPr>
-          <a:lstStyle/>
-          <a:p>
-            <a:pPr algn="l">
-              <a:lnSpc>
-                <a:spcPct val="105000"/>
-              </a:lnSpc>
-            </a:pPr>
-            <a:r>
-              <a:rPr sz="1700" b="0" i="1">
-                <a:solidFill>
-                  <a:srgbClr val="1D1D2B"/>
-                </a:solidFill>
-                <a:latin typeface="Comic Sans MS"/>
-              </a:rPr>
-              <a:t>Gartner says half of orgs will soon test if you can think WITHOUT AI. You can't cram — but you can build proof.</a:t>
-            </a:r>
-          </a:p>
-        </p:txBody>
-      </p:sp>
-      <p:sp>
-        <p:nvSpPr>
-          <p:cNvPr id="6" name="Rounded Rectangle 5"/>
-          <p:cNvSpPr/>
-          <p:nvPr/>
-        </p:nvSpPr>
-        <p:spPr>
-          <a:xfrm>
-            <a:off x="1097280" y="2468880"/>
-            <a:ext cx="2834640" cy="640080"/>
-          </a:xfrm>
-          <a:prstGeom prst="roundRect">
-            <a:avLst/>
-          </a:prstGeom>
-          <a:noFill/>
-          <a:ln w="25400">
-            <a:solidFill>
-              <a:srgbClr val="E85D2E"/>
-            </a:solidFill>
-          </a:ln>
-          <a:effectLst/>
-        </p:spPr>
-        <p:style>
-          <a:lnRef idx="1">
-            <a:schemeClr val="accent1"/>
-          </a:lnRef>
-          <a:fillRef idx="3">
-            <a:schemeClr val="accent1"/>
-          </a:fillRef>
-          <a:effectRef idx="2">
-            <a:schemeClr val="accent1"/>
-          </a:effectRef>
-          <a:fontRef idx="minor">
-            <a:schemeClr val="lt1"/>
-          </a:fontRef>
-        </p:style>
-        <p:txBody>
-          <a:bodyPr rtlCol="0" anchor="ctr"/>
-          <a:lstStyle/>
-          <a:p>
-            <a:pPr algn="ctr"/>
-          </a:p>
-        </p:txBody>
-      </p:sp>
-      <p:sp>
-        <p:nvSpPr>
-          <p:cNvPr id="7" name="TextBox 6"/>
-          <p:cNvSpPr txBox="1"/>
-          <p:nvPr/>
-        </p:nvSpPr>
-        <p:spPr>
-          <a:xfrm>
-            <a:off x="1097280" y="2523744"/>
-            <a:ext cx="2834640" cy="548640"/>
-          </a:xfrm>
-          <a:prstGeom prst="rect">
-            <a:avLst/>
-          </a:prstGeom>
-          <a:noFill/>
-        </p:spPr>
-        <p:txBody>
-          <a:bodyPr wrap="square" anchor="t">
-            <a:spAutoFit/>
-          </a:bodyPr>
-          <a:lstStyle/>
-          <a:p>
-            <a:pPr algn="ctr">
-              <a:lnSpc>
-                <a:spcPct val="105000"/>
-              </a:lnSpc>
-            </a:pPr>
-            <a:r>
-              <a:rPr sz="1800" b="1" i="0">
-                <a:solidFill>
-                  <a:srgbClr val="E85D2E"/>
-                </a:solidFill>
-                <a:latin typeface="Comic Sans MS"/>
-              </a:rPr>
-              <a:t>1 · CAUGHT IT</a:t>
-            </a:r>
-          </a:p>
-        </p:txBody>
-      </p:sp>
-      <p:sp>
-        <p:nvSpPr>
-          <p:cNvPr id="8" name="TextBox 7"/>
-          <p:cNvSpPr txBox="1"/>
-          <p:nvPr/>
-        </p:nvSpPr>
-        <p:spPr>
-          <a:xfrm>
-            <a:off x="4206240" y="2468880"/>
-            <a:ext cx="6858000" cy="640080"/>
-          </a:xfrm>
-          <a:prstGeom prst="rect">
-            <a:avLst/>
-          </a:prstGeom>
-          <a:noFill/>
-        </p:spPr>
-        <p:txBody>
-          <a:bodyPr wrap="square" anchor="ctr">
-            <a:spAutoFit/>
-          </a:bodyPr>
-          <a:lstStyle/>
-          <a:p>
-            <a:pPr algn="l">
-              <a:lnSpc>
-                <a:spcPct val="105000"/>
-              </a:lnSpc>
-            </a:pPr>
-            <a:r>
-              <a:rPr sz="1700" b="0" i="0">
-                <a:solidFill>
-                  <a:srgbClr val="1D1D2B"/>
-                </a:solidFill>
-                <a:latin typeface="Comic Sans MS"/>
-              </a:rPr>
-              <a:t>One thing AI got wrong this week that I caught &amp; fixed.</a:t>
-            </a:r>
-          </a:p>
-        </p:txBody>
-      </p:sp>
-      <p:sp>
-        <p:nvSpPr>
-          <p:cNvPr id="9" name="Rounded Rectangle 8"/>
-          <p:cNvSpPr/>
-          <p:nvPr/>
-        </p:nvSpPr>
-        <p:spPr>
-          <a:xfrm>
-            <a:off x="1097280" y="3337560"/>
-            <a:ext cx="2834640" cy="640080"/>
-          </a:xfrm>
-          <a:prstGeom prst="roundRect">
-            <a:avLst/>
-          </a:prstGeom>
-          <a:noFill/>
-          <a:ln w="25400">
-            <a:solidFill>
-              <a:srgbClr val="2E6BE8"/>
-            </a:solidFill>
-          </a:ln>
-          <a:effectLst/>
-        </p:spPr>
-        <p:style>
-          <a:lnRef idx="1">
-            <a:schemeClr val="accent1"/>
-          </a:lnRef>
-          <a:fillRef idx="3">
-            <a:schemeClr val="accent1"/>
-          </a:fillRef>
-          <a:effectRef idx="2">
-            <a:schemeClr val="accent1"/>
-          </a:effectRef>
-          <a:fontRef idx="minor">
-            <a:schemeClr val="lt1"/>
-          </a:fontRef>
-        </p:style>
-        <p:txBody>
-          <a:bodyPr rtlCol="0" anchor="ctr"/>
-          <a:lstStyle/>
-          <a:p>
-            <a:pPr algn="ctr"/>
-          </a:p>
-        </p:txBody>
-      </p:sp>
-      <p:sp>
-        <p:nvSpPr>
-          <p:cNvPr id="10" name="TextBox 9"/>
-          <p:cNvSpPr txBox="1"/>
-          <p:nvPr/>
-        </p:nvSpPr>
-        <p:spPr>
-          <a:xfrm>
-            <a:off x="1097280" y="3392424"/>
-            <a:ext cx="2834640" cy="548640"/>
-          </a:xfrm>
-          <a:prstGeom prst="rect">
-            <a:avLst/>
-          </a:prstGeom>
-          <a:noFill/>
-        </p:spPr>
-        <p:txBody>
-          <a:bodyPr wrap="square" anchor="t">
-            <a:spAutoFit/>
-          </a:bodyPr>
-          <a:lstStyle/>
-          <a:p>
-            <a:pPr algn="ctr">
-              <a:lnSpc>
-                <a:spcPct val="105000"/>
-              </a:lnSpc>
-            </a:pPr>
-            <a:r>
-              <a:rPr sz="1800" b="1" i="0">
-                <a:solidFill>
-                  <a:srgbClr val="2E6BE8"/>
-                </a:solidFill>
-                <a:latin typeface="Comic Sans MS"/>
-              </a:rPr>
-              <a:t>2 · OVERRODE</a:t>
-            </a:r>
-          </a:p>
-        </p:txBody>
-      </p:sp>
-      <p:sp>
-        <p:nvSpPr>
-          <p:cNvPr id="11" name="TextBox 10"/>
-          <p:cNvSpPr txBox="1"/>
-          <p:nvPr/>
-        </p:nvSpPr>
-        <p:spPr>
-          <a:xfrm>
-            <a:off x="4206240" y="3337560"/>
-            <a:ext cx="6858000" cy="640080"/>
-          </a:xfrm>
-          <a:prstGeom prst="rect">
-            <a:avLst/>
-          </a:prstGeom>
-          <a:noFill/>
-        </p:spPr>
-        <p:txBody>
-          <a:bodyPr wrap="square" anchor="ctr">
-            <a:spAutoFit/>
-          </a:bodyPr>
-          <a:lstStyle/>
-          <a:p>
-            <a:pPr algn="l">
-              <a:lnSpc>
-                <a:spcPct val="105000"/>
-              </a:lnSpc>
-            </a:pPr>
-            <a:r>
-              <a:rPr sz="1700" b="0" i="0">
-                <a:solidFill>
-                  <a:srgbClr val="1D1D2B"/>
-                </a:solidFill>
-                <a:latin typeface="Comic Sans MS"/>
-              </a:rPr>
-              <a:t>One time I chose against the AI's suggestion — and why.</a:t>
-            </a:r>
-          </a:p>
-        </p:txBody>
-      </p:sp>
-      <p:sp>
-        <p:nvSpPr>
-          <p:cNvPr id="12" name="Rounded Rectangle 11"/>
-          <p:cNvSpPr/>
-          <p:nvPr/>
-        </p:nvSpPr>
-        <p:spPr>
-          <a:xfrm>
-            <a:off x="1097280" y="4206240"/>
-            <a:ext cx="2834640" cy="640080"/>
-          </a:xfrm>
-          <a:prstGeom prst="roundRect">
-            <a:avLst/>
-          </a:prstGeom>
-          <a:noFill/>
-          <a:ln w="25400">
-            <a:solidFill>
-              <a:srgbClr val="2EA05A"/>
-            </a:solidFill>
-          </a:ln>
-          <a:effectLst/>
-        </p:spPr>
-        <p:style>
-          <a:lnRef idx="1">
-            <a:schemeClr val="accent1"/>
-          </a:lnRef>
-          <a:fillRef idx="3">
-            <a:schemeClr val="accent1"/>
-          </a:fillRef>
-          <a:effectRef idx="2">
-            <a:schemeClr val="accent1"/>
-          </a:effectRef>
-          <a:fontRef idx="minor">
-            <a:schemeClr val="lt1"/>
-          </a:fontRef>
-        </p:style>
-        <p:txBody>
-          <a:bodyPr rtlCol="0" anchor="ctr"/>
-          <a:lstStyle/>
-          <a:p>
-            <a:pPr algn="ctr"/>
-          </a:p>
-        </p:txBody>
-      </p:sp>
-      <p:sp>
-        <p:nvSpPr>
           <p:cNvPr id="13" name="TextBox 12"/>
           <p:cNvSpPr txBox="1"/>
           <p:nvPr/>
@@ -6444,7 +5639,7 @@
 </p:sld>
 </file>
 
-<file path=ppt/slides/slide6.xml><?xml version="1.0" encoding="utf-8"?>
+<file path=ppt/slides/slide5.xml><?xml version="1.0" encoding="utf-8"?>
 <p:sld xmlns:a="http://schemas.openxmlformats.org/drawingml/2006/main" xmlns:p="http://schemas.openxmlformats.org/presentationml/2006/main" xmlns:r="http://schemas.openxmlformats.org/officeDocument/2006/relationships">
   <p:cSld>
     <p:bg>
@@ -6490,13 +5685,13 @@
               </a:lnSpc>
             </a:pPr>
             <a:r>
-              <a:rPr sz="3800" b="1" i="0">
+              <a:rPr sz="4000" b="1" i="0">
                 <a:solidFill>
                   <a:srgbClr val="FBF7EE"/>
                 </a:solidFill>
                 <a:latin typeface="Comic Sans MS"/>
               </a:rPr>
-              <a:t>Bottom line for the fortnight</a:t>
+              <a:t>Bottom line</a:t>
             </a:r>
           </a:p>
         </p:txBody>
@@ -6510,17 +5705,17 @@
         <p:spPr>
           <a:xfrm>
             <a:off x="960120" y="2286000"/>
-            <a:ext cx="4754880" cy="109728"/>
+            <a:ext cx="3108960" cy="109728"/>
           </a:xfrm>
           <a:prstGeom prst="roundRect">
             <a:avLst/>
           </a:prstGeom>
           <a:solidFill>
-            <a:srgbClr val="E85D2E"/>
+            <a:srgbClr val="2EA05A"/>
           </a:solidFill>
           <a:ln w="6350">
             <a:solidFill>
-              <a:srgbClr val="E85D2E"/>
+              <a:srgbClr val="2EA05A"/>
             </a:solidFill>
           </a:ln>
           <a:effectLst/>
@@ -6581,7 +5776,7 @@
                 </a:solidFill>
                 <a:latin typeface="Comic Sans MS"/>
               </a:rPr>
-              <a:t>No new magnitude — higher resolution.</a:t>
+              <a:t>A genuinely quiet day.</a:t>
             </a:r>
           </a:p>
           <a:p>
@@ -6613,7 +5808,7 @@
                 </a:solidFill>
                 <a:latin typeface="Comic Sans MS"/>
               </a:rPr>
-              <a:t>The July playbook stands: AI × critical thinking × domain.</a:t>
+              <a:t>The 31 July Scoreboard is the current state — no correction needed.</a:t>
             </a:r>
           </a:p>
         </p:txBody>
@@ -6652,7 +5847,7 @@
                 </a:solidFill>
                 <a:latin typeface="Comic Sans MS"/>
               </a:rPr>
-              <a:t>The one fresh instruction is personal: start a Judgment Journal. The era of proving you can</a:t>
+              <a:t>The move is unchanged: AI literacy × critical thinking × domain × reskill-ahead-of-the-tool.</a:t>
             </a:r>
           </a:p>
           <a:p>
@@ -6668,7 +5863,7 @@
                 </a:solidFill>
                 <a:latin typeface="Comic Sans MS"/>
               </a:rPr>
-              <a:t>think without the machine is arriving faster than the headline numbers move.</a:t>
+              <a:t>One fresh personal step: start a Judgment Journal alongside your Reskill Ledger.</a:t>
             </a:r>
           </a:p>
         </p:txBody>

</xml_diff>